<commit_message>
dummy data upload complete.
</commit_message>
<xml_diff>
--- a/file structure.pptx
+++ b/file structure.pptx
@@ -133,7 +133,7 @@
   <pc:docChgLst>
     <pc:chgData name="Ayman Sadek" userId="752c5ff3-fa6e-41ca-8b19-8aac695725de" providerId="ADAL" clId="{45BBD6AE-3865-4F37-ACB6-3E0A46E3E7F1}"/>
     <pc:docChg chg="undo custSel modSld">
-      <pc:chgData name="Ayman Sadek" userId="752c5ff3-fa6e-41ca-8b19-8aac695725de" providerId="ADAL" clId="{45BBD6AE-3865-4F37-ACB6-3E0A46E3E7F1}" dt="2024-05-22T10:51:44.966" v="826" actId="20577"/>
+      <pc:chgData name="Ayman Sadek" userId="752c5ff3-fa6e-41ca-8b19-8aac695725de" providerId="ADAL" clId="{45BBD6AE-3865-4F37-ACB6-3E0A46E3E7F1}" dt="2024-05-23T14:04:51.501" v="883" actId="27636"/>
       <pc:docMkLst>
         <pc:docMk/>
       </pc:docMkLst>
@@ -161,13 +161,13 @@
         </pc:spChg>
       </pc:sldChg>
       <pc:sldChg chg="addSp modSp mod">
-        <pc:chgData name="Ayman Sadek" userId="752c5ff3-fa6e-41ca-8b19-8aac695725de" providerId="ADAL" clId="{45BBD6AE-3865-4F37-ACB6-3E0A46E3E7F1}" dt="2024-05-22T10:51:44.966" v="826" actId="20577"/>
+        <pc:chgData name="Ayman Sadek" userId="752c5ff3-fa6e-41ca-8b19-8aac695725de" providerId="ADAL" clId="{45BBD6AE-3865-4F37-ACB6-3E0A46E3E7F1}" dt="2024-05-23T14:04:51.501" v="883" actId="27636"/>
         <pc:sldMkLst>
           <pc:docMk/>
           <pc:sldMk cId="55454255" sldId="259"/>
         </pc:sldMkLst>
         <pc:spChg chg="mod">
-          <ac:chgData name="Ayman Sadek" userId="752c5ff3-fa6e-41ca-8b19-8aac695725de" providerId="ADAL" clId="{45BBD6AE-3865-4F37-ACB6-3E0A46E3E7F1}" dt="2024-05-22T08:50:57.614" v="794" actId="14100"/>
+          <ac:chgData name="Ayman Sadek" userId="752c5ff3-fa6e-41ca-8b19-8aac695725de" providerId="ADAL" clId="{45BBD6AE-3865-4F37-ACB6-3E0A46E3E7F1}" dt="2024-05-23T14:04:51.501" v="883" actId="27636"/>
           <ac:spMkLst>
             <pc:docMk/>
             <pc:sldMk cId="55454255" sldId="259"/>
@@ -175,7 +175,7 @@
           </ac:spMkLst>
         </pc:spChg>
         <pc:spChg chg="add mod">
-          <ac:chgData name="Ayman Sadek" userId="752c5ff3-fa6e-41ca-8b19-8aac695725de" providerId="ADAL" clId="{45BBD6AE-3865-4F37-ACB6-3E0A46E3E7F1}" dt="2024-05-22T10:51:44.966" v="826" actId="20577"/>
+          <ac:chgData name="Ayman Sadek" userId="752c5ff3-fa6e-41ca-8b19-8aac695725de" providerId="ADAL" clId="{45BBD6AE-3865-4F37-ACB6-3E0A46E3E7F1}" dt="2024-05-23T12:16:10.381" v="858" actId="20577"/>
           <ac:spMkLst>
             <pc:docMk/>
             <pc:sldMk cId="55454255" sldId="259"/>
@@ -7735,7 +7735,7 @@
           <a:p>
             <a:fld id="{9319ECE0-7E04-469A-8927-35E30D37E6AA}" type="datetimeFigureOut">
               <a:rPr lang="en-GB" smtClean="0"/>
-              <a:t>22/05/2024</a:t>
+              <a:t>23/05/2024</a:t>
             </a:fld>
             <a:endParaRPr lang="en-GB"/>
           </a:p>
@@ -7935,7 +7935,7 @@
           <a:p>
             <a:fld id="{9319ECE0-7E04-469A-8927-35E30D37E6AA}" type="datetimeFigureOut">
               <a:rPr lang="en-GB" smtClean="0"/>
-              <a:t>22/05/2024</a:t>
+              <a:t>23/05/2024</a:t>
             </a:fld>
             <a:endParaRPr lang="en-GB"/>
           </a:p>
@@ -8145,7 +8145,7 @@
           <a:p>
             <a:fld id="{9319ECE0-7E04-469A-8927-35E30D37E6AA}" type="datetimeFigureOut">
               <a:rPr lang="en-GB" smtClean="0"/>
-              <a:t>22/05/2024</a:t>
+              <a:t>23/05/2024</a:t>
             </a:fld>
             <a:endParaRPr lang="en-GB"/>
           </a:p>
@@ -8345,7 +8345,7 @@
           <a:p>
             <a:fld id="{9319ECE0-7E04-469A-8927-35E30D37E6AA}" type="datetimeFigureOut">
               <a:rPr lang="en-GB" smtClean="0"/>
-              <a:t>22/05/2024</a:t>
+              <a:t>23/05/2024</a:t>
             </a:fld>
             <a:endParaRPr lang="en-GB"/>
           </a:p>
@@ -8621,7 +8621,7 @@
           <a:p>
             <a:fld id="{9319ECE0-7E04-469A-8927-35E30D37E6AA}" type="datetimeFigureOut">
               <a:rPr lang="en-GB" smtClean="0"/>
-              <a:t>22/05/2024</a:t>
+              <a:t>23/05/2024</a:t>
             </a:fld>
             <a:endParaRPr lang="en-GB"/>
           </a:p>
@@ -8889,7 +8889,7 @@
           <a:p>
             <a:fld id="{9319ECE0-7E04-469A-8927-35E30D37E6AA}" type="datetimeFigureOut">
               <a:rPr lang="en-GB" smtClean="0"/>
-              <a:t>22/05/2024</a:t>
+              <a:t>23/05/2024</a:t>
             </a:fld>
             <a:endParaRPr lang="en-GB"/>
           </a:p>
@@ -9304,7 +9304,7 @@
           <a:p>
             <a:fld id="{9319ECE0-7E04-469A-8927-35E30D37E6AA}" type="datetimeFigureOut">
               <a:rPr lang="en-GB" smtClean="0"/>
-              <a:t>22/05/2024</a:t>
+              <a:t>23/05/2024</a:t>
             </a:fld>
             <a:endParaRPr lang="en-GB"/>
           </a:p>
@@ -9446,7 +9446,7 @@
           <a:p>
             <a:fld id="{9319ECE0-7E04-469A-8927-35E30D37E6AA}" type="datetimeFigureOut">
               <a:rPr lang="en-GB" smtClean="0"/>
-              <a:t>22/05/2024</a:t>
+              <a:t>23/05/2024</a:t>
             </a:fld>
             <a:endParaRPr lang="en-GB"/>
           </a:p>
@@ -9559,7 +9559,7 @@
           <a:p>
             <a:fld id="{9319ECE0-7E04-469A-8927-35E30D37E6AA}" type="datetimeFigureOut">
               <a:rPr lang="en-GB" smtClean="0"/>
-              <a:t>22/05/2024</a:t>
+              <a:t>23/05/2024</a:t>
             </a:fld>
             <a:endParaRPr lang="en-GB"/>
           </a:p>
@@ -9872,7 +9872,7 @@
           <a:p>
             <a:fld id="{9319ECE0-7E04-469A-8927-35E30D37E6AA}" type="datetimeFigureOut">
               <a:rPr lang="en-GB" smtClean="0"/>
-              <a:t>22/05/2024</a:t>
+              <a:t>23/05/2024</a:t>
             </a:fld>
             <a:endParaRPr lang="en-GB"/>
           </a:p>
@@ -10161,7 +10161,7 @@
           <a:p>
             <a:fld id="{9319ECE0-7E04-469A-8927-35E30D37E6AA}" type="datetimeFigureOut">
               <a:rPr lang="en-GB" smtClean="0"/>
-              <a:t>22/05/2024</a:t>
+              <a:t>23/05/2024</a:t>
             </a:fld>
             <a:endParaRPr lang="en-GB"/>
           </a:p>
@@ -10404,7 +10404,7 @@
           <a:p>
             <a:fld id="{9319ECE0-7E04-469A-8927-35E30D37E6AA}" type="datetimeFigureOut">
               <a:rPr lang="en-GB" smtClean="0"/>
-              <a:t>22/05/2024</a:t>
+              <a:t>23/05/2024</a:t>
             </a:fld>
             <a:endParaRPr lang="en-GB"/>
           </a:p>
@@ -11264,7 +11264,7 @@
         </p:spPr>
         <p:txBody>
           <a:bodyPr>
-            <a:normAutofit fontScale="92500" lnSpcReduction="10000"/>
+            <a:normAutofit fontScale="77500" lnSpcReduction="20000"/>
           </a:bodyPr>
           <a:lstStyle/>
           <a:p>
@@ -11279,7 +11279,7 @@
           <a:p>
             <a:r>
               <a:rPr lang="en-US" dirty="0"/>
-              <a:t>NH_RRMS_BC_TA616.rds</a:t>
+              <a:t>df_nh_rrms_bc_ta616.rds</a:t>
             </a:r>
           </a:p>
           <a:p>
@@ -11294,7 +11294,7 @@
           <a:p>
             <a:r>
               <a:rPr lang="en-US" dirty="0" err="1"/>
-              <a:t>all_cause_mortality.rds</a:t>
+              <a:t>df_all_cause_mortality.rds</a:t>
             </a:r>
             <a:endParaRPr lang="en-US" dirty="0"/>
           </a:p>
@@ -11310,7 +11310,7 @@
           <a:p>
             <a:r>
               <a:rPr lang="en-US" dirty="0" err="1"/>
-              <a:t>baseline_severity.rds</a:t>
+              <a:t>df_baseline_severity.rds</a:t>
             </a:r>
             <a:endParaRPr lang="en-US" dirty="0"/>
           </a:p>
@@ -11327,21 +11327,34 @@
           <a:p>
             <a:r>
               <a:rPr lang="en-US" dirty="0" err="1"/>
+              <a:t>df_init_params.rds</a:t>
+            </a:r>
+            <a:endParaRPr lang="en-US" dirty="0"/>
+          </a:p>
+          <a:p>
+            <a:r>
+              <a:rPr lang="en-US" dirty="0" err="1"/>
               <a:t>df_relapse.rds</a:t>
             </a:r>
             <a:endParaRPr lang="en-US" dirty="0"/>
           </a:p>
           <a:p>
             <a:r>
+              <a:rPr lang="en-US" dirty="0"/>
+              <a:t>df_adverse_events_probabilities_ta616.rds</a:t>
+            </a:r>
+          </a:p>
+          <a:p>
+            <a:r>
               <a:rPr lang="en-US" dirty="0" err="1"/>
-              <a:t>carer_disutilities.rds</a:t>
+              <a:t>df_duration_relapse.rds</a:t>
             </a:r>
             <a:endParaRPr lang="en-US" dirty="0"/>
           </a:p>
           <a:p>
             <a:r>
               <a:rPr lang="en-US" dirty="0"/>
-              <a:t>df_adverse_events_probabilities_ta616.rds</a:t>
+              <a:t>df_trt_discont_ta616.rds</a:t>
             </a:r>
           </a:p>
         </p:txBody>
@@ -11371,7 +11384,7 @@
         </p:spPr>
         <p:txBody>
           <a:bodyPr vert="horz" lIns="91440" tIns="45720" rIns="91440" bIns="45720" rtlCol="0">
-            <a:normAutofit/>
+            <a:normAutofit fontScale="85000" lnSpcReduction="20000"/>
           </a:bodyPr>
           <a:lstStyle>
             <a:lvl1pPr marL="228600" indent="-228600" algn="l" defTabSz="914400" rtl="0" eaLnBrk="1" latinLnBrk="0" hangingPunct="1">
@@ -11549,10 +11562,9 @@
           </a:p>
           <a:p>
             <a:r>
-              <a:rPr lang="en-US" dirty="0" err="1"/>
-              <a:t>df_u_adverse_events.rds</a:t>
+              <a:rPr lang="en-US" dirty="0"/>
+              <a:t>df_u_adverse_events_ta616.rds</a:t>
             </a:r>
-            <a:endParaRPr lang="en-US" dirty="0"/>
           </a:p>
           <a:p>
             <a:r>
@@ -11563,14 +11575,18 @@
           </a:p>
           <a:p>
             <a:r>
-              <a:rPr lang="en-US" dirty="0" err="1"/>
-              <a:t>edss_utilities.rds</a:t>
+              <a:rPr lang="en-US" dirty="0"/>
+              <a:t>df_u_edss_ta616</a:t>
             </a:r>
-            <a:endParaRPr lang="en-US" dirty="0"/>
+          </a:p>
+          <a:p>
+            <a:r>
+              <a:rPr lang="en-US" dirty="0"/>
+              <a:t>df_u_carer_ta616</a:t>
+            </a:r>
           </a:p>
           <a:p>
             <a:pPr marL="0" indent="0">
-              <a:buFont typeface="Arial" panose="020B0604020202020204" pitchFamily="34" charset="0"/>
               <a:buNone/>
             </a:pPr>
             <a:r>
@@ -11597,18 +11613,28 @@
           </a:p>
           <a:p>
             <a:r>
-              <a:rPr lang="en-US"/>
+              <a:rPr lang="en-US" dirty="0" err="1"/>
+              <a:t>df_c_relapse.rds</a:t>
+            </a:r>
+            <a:endParaRPr lang="en-US" dirty="0"/>
+          </a:p>
+          <a:p>
+            <a:r>
+              <a:rPr lang="en-US" dirty="0"/>
               <a:t>df_c_direct_edss_ta616.rds</a:t>
             </a:r>
           </a:p>
           <a:p>
             <a:r>
-              <a:rPr lang="pl-PL"/>
-              <a:t>df</a:t>
+              <a:rPr lang="pl-PL" dirty="0"/>
+              <a:t>df_c_drugs_ta616.rds</a:t>
             </a:r>
+            <a:endParaRPr lang="en-US" dirty="0"/>
+          </a:p>
+          <a:p>
             <a:r>
-              <a:rPr lang="pl-PL" dirty="0"/>
-              <a:t>_c_drugs_ta616.rds</a:t>
+              <a:rPr lang="fr-FR" dirty="0"/>
+              <a:t>df_c_disutilities_ta616.rds</a:t>
             </a:r>
             <a:endParaRPr lang="en-US" dirty="0"/>
           </a:p>
@@ -12419,25 +12445,6 @@
 </file>
 
 <file path=customXml/item1.xml><?xml version="1.0" encoding="utf-8"?>
-<?mso-contentType ?>
-<FormTemplates xmlns="http://schemas.microsoft.com/sharepoint/v3/contenttype/forms">
-  <Display>DocumentLibraryForm</Display>
-  <Edit>DocumentLibraryForm</Edit>
-  <New>DocumentLibraryForm</New>
-</FormTemplates>
-</file>
-
-<file path=customXml/item2.xml><?xml version="1.0" encoding="utf-8"?>
-<p:properties xmlns:p="http://schemas.microsoft.com/office/2006/metadata/properties" xmlns:xsi="http://www.w3.org/2001/XMLSchema-instance" xmlns:pc="http://schemas.microsoft.com/office/infopath/2007/PartnerControls">
-  <documentManagement>
-    <lcf76f155ced4ddcb4097134ff3c332f xmlns="a4e98822-f433-4c96-8830-5cb2d7491f7d">
-      <Terms xmlns="http://schemas.microsoft.com/office/infopath/2007/PartnerControls"/>
-    </lcf76f155ced4ddcb4097134ff3c332f>
-  </documentManagement>
-</p:properties>
-</file>
-
-<file path=customXml/item3.xml><?xml version="1.0" encoding="utf-8"?>
 <ct:contentTypeSchema xmlns:ct="http://schemas.microsoft.com/office/2006/metadata/contentType" xmlns:ma="http://schemas.microsoft.com/office/2006/metadata/properties/metaAttributes" ct:_="" ma:_="" ma:contentTypeName="Document" ma:contentTypeID="0x010100ACE3D2A8E3060445845CB33F649944D9" ma:contentTypeVersion="12" ma:contentTypeDescription="Create a new document." ma:contentTypeScope="" ma:versionID="7c8efc5d897a5a54c153d61be50fc1e0">
   <xsd:schema xmlns:xsd="http://www.w3.org/2001/XMLSchema" xmlns:xs="http://www.w3.org/2001/XMLSchema" xmlns:p="http://schemas.microsoft.com/office/2006/metadata/properties" xmlns:ns2="a4e98822-f433-4c96-8830-5cb2d7491f7d" xmlns:ns3="adc125f1-7df9-46f4-a9a7-022dd426a2bb" targetNamespace="http://schemas.microsoft.com/office/2006/metadata/properties" ma:root="true" ma:fieldsID="7c927ce20f93a00fedc297caf603d12c" ns2:_="" ns3:_="">
     <xsd:import namespace="a4e98822-f433-4c96-8830-5cb2d7491f7d"/>
@@ -12648,25 +12655,26 @@
 </ct:contentTypeSchema>
 </file>
 
-<file path=customXml/itemProps1.xml><?xml version="1.0" encoding="utf-8"?>
-<ds:datastoreItem xmlns:ds="http://schemas.openxmlformats.org/officeDocument/2006/customXml" ds:itemID="{EF7D71B8-A0A0-4AAA-A290-E2ABB53599F2}">
-  <ds:schemaRefs>
-    <ds:schemaRef ds:uri="http://schemas.microsoft.com/sharepoint/v3/contenttype/forms"/>
-  </ds:schemaRefs>
-</ds:datastoreItem>
+<file path=customXml/item2.xml><?xml version="1.0" encoding="utf-8"?>
+<p:properties xmlns:p="http://schemas.microsoft.com/office/2006/metadata/properties" xmlns:xsi="http://www.w3.org/2001/XMLSchema-instance" xmlns:pc="http://schemas.microsoft.com/office/infopath/2007/PartnerControls">
+  <documentManagement>
+    <lcf76f155ced4ddcb4097134ff3c332f xmlns="a4e98822-f433-4c96-8830-5cb2d7491f7d">
+      <Terms xmlns="http://schemas.microsoft.com/office/infopath/2007/PartnerControls"/>
+    </lcf76f155ced4ddcb4097134ff3c332f>
+  </documentManagement>
+</p:properties>
 </file>
 
-<file path=customXml/itemProps2.xml><?xml version="1.0" encoding="utf-8"?>
-<ds:datastoreItem xmlns:ds="http://schemas.openxmlformats.org/officeDocument/2006/customXml" ds:itemID="{18B68755-2212-408D-94A9-2FD4441F68F3}">
-  <ds:schemaRefs>
-    <ds:schemaRef ds:uri="http://schemas.microsoft.com/office/2006/metadata/properties"/>
-    <ds:schemaRef ds:uri="http://schemas.microsoft.com/office/infopath/2007/PartnerControls"/>
-    <ds:schemaRef ds:uri="a4e98822-f433-4c96-8830-5cb2d7491f7d"/>
-  </ds:schemaRefs>
-</ds:datastoreItem>
+<file path=customXml/item3.xml><?xml version="1.0" encoding="utf-8"?>
+<?mso-contentType ?>
+<FormTemplates xmlns="http://schemas.microsoft.com/sharepoint/v3/contenttype/forms">
+  <Display>DocumentLibraryForm</Display>
+  <Edit>DocumentLibraryForm</Edit>
+  <New>DocumentLibraryForm</New>
+</FormTemplates>
 </file>
 
-<file path=customXml/itemProps3.xml><?xml version="1.0" encoding="utf-8"?>
+<file path=customXml/itemProps1.xml><?xml version="1.0" encoding="utf-8"?>
 <ds:datastoreItem xmlns:ds="http://schemas.openxmlformats.org/officeDocument/2006/customXml" ds:itemID="{6113E222-2375-42C6-BE16-238BCB01EE1B}">
   <ds:schemaRefs>
     <ds:schemaRef ds:uri="http://schemas.microsoft.com/office/2006/metadata/contentType"/>
@@ -12683,4 +12691,22 @@
     <ds:schemaRef ds:uri="http://schemas.microsoft.com/internal/obd"/>
   </ds:schemaRefs>
 </ds:datastoreItem>
+</file>
+
+<file path=customXml/itemProps2.xml><?xml version="1.0" encoding="utf-8"?>
+<ds:datastoreItem xmlns:ds="http://schemas.openxmlformats.org/officeDocument/2006/customXml" ds:itemID="{18B68755-2212-408D-94A9-2FD4441F68F3}">
+  <ds:schemaRefs>
+    <ds:schemaRef ds:uri="http://schemas.microsoft.com/office/2006/metadata/properties"/>
+    <ds:schemaRef ds:uri="http://schemas.microsoft.com/office/infopath/2007/PartnerControls"/>
+    <ds:schemaRef ds:uri="a4e98822-f433-4c96-8830-5cb2d7491f7d"/>
+  </ds:schemaRefs>
+</ds:datastoreItem>
+</file>
+
+<file path=customXml/itemProps3.xml><?xml version="1.0" encoding="utf-8"?>
+<ds:datastoreItem xmlns:ds="http://schemas.openxmlformats.org/officeDocument/2006/customXml" ds:itemID="{EF7D71B8-A0A0-4AAA-A290-E2ABB53599F2}">
+  <ds:schemaRefs>
+    <ds:schemaRef ds:uri="http://schemas.microsoft.com/sharepoint/v3/contenttype/forms"/>
+  </ds:schemaRefs>
+</ds:datastoreItem>
 </file>
</xml_diff>